<commit_message>
feat: Slide 3 rewrite + compressed demo video (17MB)
</commit_message>
<xml_diff>
--- a/assets/Hermes-Demo.pptx
+++ b/assets/Hermes-Demo.pptx
@@ -1153,7 +1153,7 @@
         </p:nvSpPr>
         <p:spPr>
           <a:xfrm>
-            <a:off x="731520" y="1371600"/>
+            <a:off x="731520" y="701068"/>
             <a:ext cx="7680960" cy="1097280"/>
           </a:xfrm>
           <a:prstGeom prst="rect">
@@ -1192,7 +1192,7 @@
         </p:nvSpPr>
         <p:spPr>
           <a:xfrm>
-            <a:off x="731520" y="2560320"/>
+            <a:off x="731520" y="1879699"/>
             <a:ext cx="2286000" cy="36576"/>
           </a:xfrm>
           <a:prstGeom prst="rect">
@@ -1219,7 +1219,7 @@
         </p:nvSpPr>
         <p:spPr>
           <a:xfrm>
-            <a:off x="731520" y="2743200"/>
+            <a:off x="731520" y="2115554"/>
             <a:ext cx="7680960" cy="731520"/>
           </a:xfrm>
           <a:prstGeom prst="rect">
@@ -1236,7 +1236,7 @@
               <a:buNone/>
             </a:pPr>
             <a:r>
-              <a:rPr lang="en-US" sz="2000" i="1" dirty="0">
+              <a:rPr lang="en-US" sz="2000" i="1" dirty="0" err="1">
                 <a:solidFill>
                   <a:srgbClr val="94A3B8"/>
                 </a:solidFill>
@@ -1244,9 +1244,189 @@
                 <a:ea typeface="Calibri" pitchFamily="34" charset="-122"/>
                 <a:cs typeface="Calibri" pitchFamily="34" charset="-120"/>
               </a:rPr>
-              <a:t>这场分享，是 Hermes 自己准备的</a:t>
+              <a:t>一场</a:t>
+            </a:r>
+            <a:r>
+              <a:rPr lang="zh-CN" altLang="en-US" sz="2000" i="1" dirty="0">
+                <a:solidFill>
+                  <a:srgbClr val="94A3B8"/>
+                </a:solidFill>
+                <a:latin typeface="Calibri" pitchFamily="34" charset="0"/>
+                <a:ea typeface="Calibri" pitchFamily="34" charset="-122"/>
+                <a:cs typeface="Calibri" pitchFamily="34" charset="-120"/>
+              </a:rPr>
+              <a:t>由 </a:t>
+            </a:r>
+            <a:r>
+              <a:rPr lang="en-US" sz="2000" i="1" dirty="0">
+                <a:solidFill>
+                  <a:srgbClr val="94A3B8"/>
+                </a:solidFill>
+                <a:latin typeface="Calibri" pitchFamily="34" charset="0"/>
+                <a:ea typeface="Calibri" pitchFamily="34" charset="-122"/>
+                <a:cs typeface="Calibri" pitchFamily="34" charset="-120"/>
+              </a:rPr>
+              <a:t>Hermes </a:t>
+            </a:r>
+            <a:r>
+              <a:rPr lang="en-US" sz="2000" i="1">
+                <a:solidFill>
+                  <a:srgbClr val="94A3B8"/>
+                </a:solidFill>
+                <a:latin typeface="Calibri" pitchFamily="34" charset="0"/>
+                <a:ea typeface="Calibri" pitchFamily="34" charset="-122"/>
+                <a:cs typeface="Calibri" pitchFamily="34" charset="-120"/>
+              </a:rPr>
+              <a:t>准备的</a:t>
+            </a:r>
+            <a:r>
+              <a:rPr lang="zh-CN" altLang="en-US" sz="2000" i="1" dirty="0">
+                <a:solidFill>
+                  <a:srgbClr val="94A3B8"/>
+                </a:solidFill>
+                <a:latin typeface="Calibri" pitchFamily="34" charset="0"/>
+                <a:ea typeface="Calibri" pitchFamily="34" charset="-122"/>
+                <a:cs typeface="Calibri" pitchFamily="34" charset="-120"/>
+              </a:rPr>
+              <a:t>分享</a:t>
             </a:r>
             <a:endParaRPr lang="en-US" sz="2000" dirty="0"/>
+          </a:p>
+        </p:txBody>
+      </p:sp>
+      <p:sp>
+        <p:nvSpPr>
+          <p:cNvPr id="6" name="TextBox 5">
+            <a:extLst>
+              <a:ext uri="{FF2B5EF4-FFF2-40B4-BE49-F238E27FC236}">
+                <a16:creationId xmlns:a16="http://schemas.microsoft.com/office/drawing/2014/main" id="{4315E540-3C7C-D4AB-85B8-188946747FE7}"/>
+              </a:ext>
+            </a:extLst>
+          </p:cNvPr>
+          <p:cNvSpPr txBox="1"/>
+          <p:nvPr/>
+        </p:nvSpPr>
+        <p:spPr>
+          <a:xfrm>
+            <a:off x="864366" y="3122382"/>
+            <a:ext cx="4737772" cy="646331"/>
+          </a:xfrm>
+          <a:prstGeom prst="rect">
+            <a:avLst/>
+          </a:prstGeom>
+          <a:noFill/>
+        </p:spPr>
+        <p:txBody>
+          <a:bodyPr wrap="none" rtlCol="0">
+            <a:spAutoFit/>
+          </a:bodyPr>
+          <a:lstStyle/>
+          <a:p>
+            <a:r>
+              <a:rPr lang="en-US" sz="3600" b="1" dirty="0">
+                <a:solidFill>
+                  <a:schemeClr val="bg1"/>
+                </a:solidFill>
+              </a:rPr>
+              <a:t>By</a:t>
+            </a:r>
+            <a:r>
+              <a:rPr lang="zh-CN" altLang="en-US" sz="3600" b="1" dirty="0">
+                <a:solidFill>
+                  <a:schemeClr val="bg1"/>
+                </a:solidFill>
+              </a:rPr>
+              <a:t>：</a:t>
+            </a:r>
+            <a:r>
+              <a:rPr lang="en-US" sz="3600" b="1" dirty="0">
+                <a:solidFill>
+                  <a:schemeClr val="bg1"/>
+                </a:solidFill>
+              </a:rPr>
+              <a:t>Swen</a:t>
+            </a:r>
+            <a:r>
+              <a:rPr lang="zh-CN" altLang="en-US" sz="3600" b="1" dirty="0">
+                <a:solidFill>
+                  <a:schemeClr val="bg1"/>
+                </a:solidFill>
+              </a:rPr>
+              <a:t> </a:t>
+            </a:r>
+            <a:r>
+              <a:rPr lang="en-US" altLang="zh-CN" sz="3600" b="1" dirty="0">
+                <a:solidFill>
+                  <a:schemeClr val="bg1"/>
+                </a:solidFill>
+              </a:rPr>
+              <a:t>+</a:t>
+            </a:r>
+            <a:r>
+              <a:rPr lang="zh-CN" altLang="en-US" sz="3600" b="1" dirty="0">
+                <a:solidFill>
+                  <a:schemeClr val="bg1"/>
+                </a:solidFill>
+              </a:rPr>
+              <a:t> </a:t>
+            </a:r>
+            <a:r>
+              <a:rPr lang="en-US" altLang="zh-CN" sz="3600" b="1" dirty="0" err="1">
+                <a:solidFill>
+                  <a:schemeClr val="bg1"/>
+                </a:solidFill>
+              </a:rPr>
+              <a:t>SuperSwen</a:t>
+            </a:r>
+            <a:endParaRPr lang="en-US" sz="3600" b="1" dirty="0">
+              <a:solidFill>
+                <a:schemeClr val="bg1"/>
+              </a:solidFill>
+            </a:endParaRPr>
+          </a:p>
+        </p:txBody>
+      </p:sp>
+      <p:sp>
+        <p:nvSpPr>
+          <p:cNvPr id="7" name="TextBox 6">
+            <a:extLst>
+              <a:ext uri="{FF2B5EF4-FFF2-40B4-BE49-F238E27FC236}">
+                <a16:creationId xmlns:a16="http://schemas.microsoft.com/office/drawing/2014/main" id="{DAD5E70F-BD7B-584F-ED8B-2028E49377E8}"/>
+              </a:ext>
+            </a:extLst>
+          </p:cNvPr>
+          <p:cNvSpPr txBox="1"/>
+          <p:nvPr/>
+        </p:nvSpPr>
+        <p:spPr>
+          <a:xfrm>
+            <a:off x="864366" y="3967992"/>
+            <a:ext cx="3021981" cy="338554"/>
+          </a:xfrm>
+          <a:prstGeom prst="rect">
+            <a:avLst/>
+          </a:prstGeom>
+          <a:noFill/>
+        </p:spPr>
+        <p:txBody>
+          <a:bodyPr wrap="none" rtlCol="0">
+            <a:spAutoFit/>
+          </a:bodyPr>
+          <a:lstStyle/>
+          <a:p>
+            <a:r>
+              <a:rPr lang="en-US" sz="1600" dirty="0" err="1">
+                <a:solidFill>
+                  <a:schemeClr val="bg1"/>
+                </a:solidFill>
+              </a:rPr>
+              <a:t>专注工作流自动化与企业AI转型</a:t>
+            </a:r>
+            <a:endParaRPr lang="en-US" sz="1600" dirty="0">
+              <a:solidFill>
+                <a:schemeClr val="bg1"/>
+              </a:solidFill>
+            </a:endParaRPr>
           </a:p>
         </p:txBody>
       </p:sp>
@@ -1833,7 +2013,7 @@
         </p:nvSpPr>
         <p:spPr>
           <a:xfrm>
-            <a:off x="731520" y="274320"/>
+            <a:off x="731520" y="635047"/>
             <a:ext cx="7680960" cy="502920"/>
           </a:xfrm>
           <a:prstGeom prst="rect">
@@ -1872,7 +2052,7 @@
         </p:nvSpPr>
         <p:spPr>
           <a:xfrm>
-            <a:off x="731520" y="777240"/>
+            <a:off x="731520" y="1137967"/>
             <a:ext cx="7680960" cy="365760"/>
           </a:xfrm>
           <a:prstGeom prst="rect">
@@ -1911,7 +2091,7 @@
         </p:nvSpPr>
         <p:spPr>
           <a:xfrm>
-            <a:off x="731520" y="1371600"/>
+            <a:off x="731520" y="1732327"/>
             <a:ext cx="2286000" cy="2011680"/>
           </a:xfrm>
           <a:prstGeom prst="rect">
@@ -1945,7 +2125,7 @@
         </p:nvSpPr>
         <p:spPr>
           <a:xfrm>
-            <a:off x="731520" y="1371600"/>
+            <a:off x="731520" y="1732327"/>
             <a:ext cx="2286000" cy="54864"/>
           </a:xfrm>
           <a:prstGeom prst="rect">
@@ -1972,7 +2152,7 @@
         </p:nvSpPr>
         <p:spPr>
           <a:xfrm>
-            <a:off x="914400" y="1554480"/>
+            <a:off x="914400" y="1915207"/>
             <a:ext cx="1920240" cy="411480"/>
           </a:xfrm>
           <a:prstGeom prst="rect">
@@ -2011,7 +2191,7 @@
         </p:nvSpPr>
         <p:spPr>
           <a:xfrm>
-            <a:off x="914400" y="2011680"/>
+            <a:off x="914400" y="2372407"/>
             <a:ext cx="1920240" cy="1188720"/>
           </a:xfrm>
           <a:prstGeom prst="rect">
@@ -2067,7 +2247,7 @@
         </p:nvSpPr>
         <p:spPr>
           <a:xfrm>
-            <a:off x="3383280" y="1371600"/>
+            <a:off x="3383280" y="1732327"/>
             <a:ext cx="2286000" cy="2011680"/>
           </a:xfrm>
           <a:prstGeom prst="rect">
@@ -2101,7 +2281,7 @@
         </p:nvSpPr>
         <p:spPr>
           <a:xfrm>
-            <a:off x="3383280" y="1371600"/>
+            <a:off x="3383280" y="1732327"/>
             <a:ext cx="2286000" cy="54864"/>
           </a:xfrm>
           <a:prstGeom prst="rect">
@@ -2128,7 +2308,7 @@
         </p:nvSpPr>
         <p:spPr>
           <a:xfrm>
-            <a:off x="3566160" y="1554480"/>
+            <a:off x="3566160" y="1915207"/>
             <a:ext cx="1920240" cy="411480"/>
           </a:xfrm>
           <a:prstGeom prst="rect">
@@ -2167,7 +2347,7 @@
         </p:nvSpPr>
         <p:spPr>
           <a:xfrm>
-            <a:off x="3566160" y="2011680"/>
+            <a:off x="3566160" y="2372407"/>
             <a:ext cx="1920240" cy="1188720"/>
           </a:xfrm>
           <a:prstGeom prst="rect">
@@ -2240,7 +2420,7 @@
         </p:nvSpPr>
         <p:spPr>
           <a:xfrm>
-            <a:off x="6035040" y="1371600"/>
+            <a:off x="6035040" y="1732327"/>
             <a:ext cx="2286000" cy="2011680"/>
           </a:xfrm>
           <a:prstGeom prst="rect">
@@ -2274,7 +2454,7 @@
         </p:nvSpPr>
         <p:spPr>
           <a:xfrm>
-            <a:off x="6035040" y="1371600"/>
+            <a:off x="6035040" y="1732327"/>
             <a:ext cx="2286000" cy="54864"/>
           </a:xfrm>
           <a:prstGeom prst="rect">
@@ -2301,7 +2481,7 @@
         </p:nvSpPr>
         <p:spPr>
           <a:xfrm>
-            <a:off x="6217920" y="1554480"/>
+            <a:off x="6217920" y="1915207"/>
             <a:ext cx="1920240" cy="411480"/>
           </a:xfrm>
           <a:prstGeom prst="rect">
@@ -2340,7 +2520,7 @@
         </p:nvSpPr>
         <p:spPr>
           <a:xfrm>
-            <a:off x="6217920" y="2011680"/>
+            <a:off x="6217920" y="2372407"/>
             <a:ext cx="1920240" cy="1188720"/>
           </a:xfrm>
           <a:prstGeom prst="rect">
@@ -2413,7 +2593,7 @@
         </p:nvSpPr>
         <p:spPr>
           <a:xfrm>
-            <a:off x="731520" y="3840480"/>
+            <a:off x="731520" y="4033427"/>
             <a:ext cx="7680960" cy="457200"/>
           </a:xfrm>
           <a:prstGeom prst="rect">
@@ -2430,7 +2610,7 @@
               <a:buNone/>
             </a:pPr>
             <a:r>
-              <a:rPr lang="en-US" sz="1600" i="1" dirty="0">
+              <a:rPr lang="en-US" sz="1600" i="1" dirty="0" err="1">
                 <a:solidFill>
                   <a:srgbClr val="F1F5F9"/>
                 </a:solidFill>
@@ -2438,7 +2618,7 @@
                 <a:ea typeface="Calibri" pitchFamily="34" charset="-122"/>
                 <a:cs typeface="Calibri" pitchFamily="34" charset="-120"/>
               </a:rPr>
-              <a:t>从想象力到日常。从单次惊艳到持续可用。</a:t>
+              <a:t>从想象力到日常</a:t>
             </a:r>
             <a:endParaRPr lang="en-US" sz="1600" dirty="0"/>
           </a:p>
@@ -2529,7 +2709,7 @@
               <a:buNone/>
             </a:pPr>
             <a:r>
-              <a:rPr lang="en-US" sz="3200" b="1" dirty="0">
+              <a:rPr lang="en-US" sz="3200" b="1" dirty="0" err="1">
                 <a:solidFill>
                   <a:srgbClr val="F1F5F9"/>
                 </a:solidFill>
@@ -2537,7 +2717,29 @@
                 <a:ea typeface="Georgia" pitchFamily="34" charset="-122"/>
                 <a:cs typeface="Georgia" pitchFamily="34" charset="-120"/>
               </a:rPr>
-              <a:t>从零搭建 Hermes</a:t>
+              <a:t>从零搭建</a:t>
+            </a:r>
+            <a:r>
+              <a:rPr lang="en-US" sz="3200" b="1" dirty="0">
+                <a:solidFill>
+                  <a:srgbClr val="F1F5F9"/>
+                </a:solidFill>
+                <a:latin typeface="Georgia" pitchFamily="34" charset="0"/>
+                <a:ea typeface="Georgia" pitchFamily="34" charset="-122"/>
+                <a:cs typeface="Georgia" pitchFamily="34" charset="-120"/>
+              </a:rPr>
+              <a:t> Hermes</a:t>
+            </a:r>
+            <a:r>
+              <a:rPr lang="zh-CN" altLang="en-US" sz="3200" b="1" dirty="0">
+                <a:solidFill>
+                  <a:srgbClr val="F1F5F9"/>
+                </a:solidFill>
+                <a:latin typeface="Georgia" pitchFamily="34" charset="0"/>
+                <a:ea typeface="Georgia" pitchFamily="34" charset="-122"/>
+                <a:cs typeface="Georgia" pitchFamily="34" charset="-120"/>
+              </a:rPr>
+              <a:t> 的喂饭指南</a:t>
             </a:r>
             <a:endParaRPr lang="en-US" sz="3200" dirty="0"/>
           </a:p>
@@ -2578,8 +2780,8 @@
         </p:nvSpPr>
         <p:spPr>
           <a:xfrm>
-            <a:off x="731520" y="1371600"/>
-            <a:ext cx="7680960" cy="1965960"/>
+            <a:off x="731520" y="1497435"/>
+            <a:ext cx="7680960" cy="1473161"/>
           </a:xfrm>
           <a:prstGeom prst="rect">
             <a:avLst/>
@@ -2612,8 +2814,8 @@
         </p:nvSpPr>
         <p:spPr>
           <a:xfrm>
-            <a:off x="1005840" y="1508760"/>
-            <a:ext cx="7223760" cy="1691640"/>
+            <a:off x="1005840" y="1634595"/>
+            <a:ext cx="7274094" cy="1200884"/>
           </a:xfrm>
           <a:prstGeom prst="rect">
             <a:avLst/>
@@ -2633,7 +2835,7 @@
               <a:buChar char="•"/>
             </a:pPr>
             <a:r>
-              <a:rPr lang="en-US" sz="1800" dirty="0">
+              <a:rPr lang="en-US" sz="1800" dirty="0" err="1">
                 <a:solidFill>
                   <a:srgbClr val="F1F5F9"/>
                 </a:solidFill>
@@ -2641,7 +2843,18 @@
                 <a:ea typeface="Calibri" pitchFamily="34" charset="-122"/>
                 <a:cs typeface="Calibri" pitchFamily="34" charset="-120"/>
               </a:rPr>
-              <a:t>完整指南：03-hermes-guide.md（可独立分发）</a:t>
+              <a:t>关键步骤：安装</a:t>
+            </a:r>
+            <a:r>
+              <a:rPr lang="en-US" sz="1800" dirty="0">
+                <a:solidFill>
+                  <a:srgbClr val="F1F5F9"/>
+                </a:solidFill>
+                <a:latin typeface="Calibri" pitchFamily="34" charset="0"/>
+                <a:ea typeface="Calibri" pitchFamily="34" charset="-122"/>
+                <a:cs typeface="Calibri" pitchFamily="34" charset="-120"/>
+              </a:rPr>
+              <a:t> → 配置模型 → 定义 SOUL/AGENTS → 接入 Telegram → 开始使用</a:t>
             </a:r>
             <a:endParaRPr lang="en-US" sz="1800" dirty="0"/>
           </a:p>
@@ -2662,20 +2875,10 @@
                 <a:ea typeface="Calibri" pitchFamily="34" charset="-122"/>
                 <a:cs typeface="Calibri" pitchFamily="34" charset="-120"/>
               </a:rPr>
-              <a:t>关键步骤：安装 → 配置模型 → 定义 SOUL/AGENTS → 接入 Telegram → 开始使用</a:t>
-            </a:r>
-            <a:endParaRPr lang="en-US" sz="1800" dirty="0"/>
-          </a:p>
-          <a:p>
-            <a:pPr marL="342900" indent="-342900">
-              <a:spcAft>
-                <a:spcPts val="800"/>
-              </a:spcAft>
-              <a:buSzPct val="100000"/>
-              <a:buChar char="•"/>
-            </a:pPr>
-            <a:r>
-              <a:rPr lang="en-US" sz="1800" dirty="0">
+              <a:t>更多 Agent </a:t>
+            </a:r>
+            <a:r>
+              <a:rPr lang="en-US" sz="1800" dirty="0" err="1">
                 <a:solidFill>
                   <a:srgbClr val="F1F5F9"/>
                 </a:solidFill>
@@ -2683,78 +2886,53 @@
                 <a:ea typeface="Calibri" pitchFamily="34" charset="-122"/>
                 <a:cs typeface="Calibri" pitchFamily="34" charset="-120"/>
               </a:rPr>
-              <a:t>更多 Agent 搭建、商业化、创业思考 →</a:t>
-            </a:r>
-            <a:endParaRPr lang="en-US" sz="1800" dirty="0"/>
-          </a:p>
-        </p:txBody>
-      </p:sp>
-      <p:sp>
-        <p:nvSpPr>
-          <p:cNvPr id="8" name="Shape 5"/>
-          <p:cNvSpPr/>
-          <p:nvPr/>
-        </p:nvSpPr>
-        <p:spPr>
-          <a:xfrm>
-            <a:off x="731520" y="3383280"/>
-            <a:ext cx="7680960" cy="548640"/>
-          </a:xfrm>
-          <a:prstGeom prst="rect">
-            <a:avLst/>
-          </a:prstGeom>
-          <a:solidFill>
-            <a:srgbClr val="1E293B"/>
-          </a:solidFill>
-          <a:ln/>
-        </p:spPr>
-        <p:txBody>
-          <a:bodyPr/>
-          <a:lstStyle/>
-          <a:p>
-            <a:endParaRPr lang="en-US"/>
-          </a:p>
-        </p:txBody>
-      </p:sp>
-      <p:sp>
-        <p:nvSpPr>
-          <p:cNvPr id="9" name="Text 6"/>
-          <p:cNvSpPr/>
-          <p:nvPr/>
-        </p:nvSpPr>
-        <p:spPr>
-          <a:xfrm>
-            <a:off x="731520" y="3383280"/>
-            <a:ext cx="7680960" cy="548640"/>
-          </a:xfrm>
-          <a:prstGeom prst="rect">
-            <a:avLst/>
-          </a:prstGeom>
-          <a:noFill/>
-          <a:ln/>
-        </p:spPr>
-        <p:txBody>
-          <a:bodyPr wrap="square" lIns="0" tIns="0" rIns="0" bIns="0" rtlCol="0" anchor="ctr"/>
-          <a:lstStyle/>
-          <a:p>
-            <a:pPr marL="0" indent="0" algn="ctr">
-              <a:buNone/>
-            </a:pPr>
-            <a:r>
-              <a:rPr lang="en-US" sz="1800" b="1" dirty="0">
-                <a:solidFill>
-                  <a:srgbClr val="06B6D4"/>
+              <a:t>搭建、商业化、创业思考</a:t>
+            </a:r>
+            <a:r>
+              <a:rPr lang="en-US" sz="1800" dirty="0">
+                <a:solidFill>
+                  <a:srgbClr val="F1F5F9"/>
                 </a:solidFill>
                 <a:latin typeface="Calibri" pitchFamily="34" charset="0"/>
                 <a:ea typeface="Calibri" pitchFamily="34" charset="-122"/>
                 <a:cs typeface="Calibri" pitchFamily="34" charset="-120"/>
               </a:rPr>
-              <a:t>🐦 Twitter/X:  @swen_chan</a:t>
+              <a:t> </a:t>
             </a:r>
             <a:endParaRPr lang="en-US" sz="1800" dirty="0"/>
           </a:p>
         </p:txBody>
       </p:sp>
+      <p:pic>
+        <p:nvPicPr>
+          <p:cNvPr id="10" name="Picture 9" descr="A qr code on a white background&#10;&#10;AI-generated content may be incorrect.">
+            <a:extLst>
+              <a:ext uri="{FF2B5EF4-FFF2-40B4-BE49-F238E27FC236}">
+                <a16:creationId xmlns:a16="http://schemas.microsoft.com/office/drawing/2014/main" id="{7D7EEEDF-267F-00FD-94E0-BEE270DB617B}"/>
+              </a:ext>
+            </a:extLst>
+          </p:cNvPr>
+          <p:cNvPicPr>
+            <a:picLocks noChangeAspect="1"/>
+          </p:cNvPicPr>
+          <p:nvPr/>
+        </p:nvPicPr>
+        <p:blipFill>
+          <a:blip r:embed="rId3"/>
+          <a:stretch>
+            <a:fillRect/>
+          </a:stretch>
+        </p:blipFill>
+        <p:spPr>
+          <a:xfrm>
+            <a:off x="3694412" y="3304579"/>
+            <a:ext cx="1548708" cy="1473161"/>
+          </a:xfrm>
+          <a:prstGeom prst="rect">
+            <a:avLst/>
+          </a:prstGeom>
+        </p:spPr>
+      </p:pic>
     </p:spTree>
   </p:cSld>
   <p:clrMapOvr>
@@ -3160,7 +3338,7 @@
         </p:nvSpPr>
         <p:spPr>
           <a:xfrm>
-            <a:off x="731520" y="914400"/>
+            <a:off x="731520" y="636724"/>
             <a:ext cx="7680960" cy="914400"/>
           </a:xfrm>
           <a:prstGeom prst="rect">
@@ -3199,7 +3377,7 @@
         </p:nvSpPr>
         <p:spPr>
           <a:xfrm>
-            <a:off x="1097280" y="2286000"/>
+            <a:off x="1097280" y="1849772"/>
             <a:ext cx="2103120" cy="1371600"/>
           </a:xfrm>
           <a:prstGeom prst="rect">
@@ -3233,7 +3411,7 @@
         </p:nvSpPr>
         <p:spPr>
           <a:xfrm>
-            <a:off x="1097280" y="2331720"/>
+            <a:off x="1097280" y="1920659"/>
             <a:ext cx="2103120" cy="457200"/>
           </a:xfrm>
           <a:prstGeom prst="rect">
@@ -3269,7 +3447,7 @@
         </p:nvSpPr>
         <p:spPr>
           <a:xfrm>
-            <a:off x="1097280" y="2743200"/>
+            <a:off x="1097280" y="2332139"/>
             <a:ext cx="2103120" cy="320040"/>
           </a:xfrm>
           <a:prstGeom prst="rect">
@@ -3308,7 +3486,7 @@
         </p:nvSpPr>
         <p:spPr>
           <a:xfrm>
-            <a:off x="1097280" y="3063240"/>
+            <a:off x="1097280" y="2652179"/>
             <a:ext cx="2103120" cy="411480"/>
           </a:xfrm>
           <a:prstGeom prst="rect">
@@ -3347,7 +3525,7 @@
         </p:nvSpPr>
         <p:spPr>
           <a:xfrm>
-            <a:off x="3566160" y="2286000"/>
+            <a:off x="3566160" y="1849772"/>
             <a:ext cx="2103120" cy="1371600"/>
           </a:xfrm>
           <a:prstGeom prst="rect">
@@ -3381,7 +3559,7 @@
         </p:nvSpPr>
         <p:spPr>
           <a:xfrm>
-            <a:off x="3566160" y="2331720"/>
+            <a:off x="3566160" y="1920659"/>
             <a:ext cx="2103120" cy="457200"/>
           </a:xfrm>
           <a:prstGeom prst="rect">
@@ -3417,7 +3595,7 @@
         </p:nvSpPr>
         <p:spPr>
           <a:xfrm>
-            <a:off x="3566160" y="2743200"/>
+            <a:off x="3566160" y="2332139"/>
             <a:ext cx="2103120" cy="320040"/>
           </a:xfrm>
           <a:prstGeom prst="rect">
@@ -3456,7 +3634,7 @@
         </p:nvSpPr>
         <p:spPr>
           <a:xfrm>
-            <a:off x="3566160" y="3063240"/>
+            <a:off x="3566160" y="2652179"/>
             <a:ext cx="2103120" cy="411480"/>
           </a:xfrm>
           <a:prstGeom prst="rect">
@@ -3495,7 +3673,7 @@
         </p:nvSpPr>
         <p:spPr>
           <a:xfrm>
-            <a:off x="6035040" y="2286000"/>
+            <a:off x="6035040" y="1849772"/>
             <a:ext cx="2103120" cy="1371600"/>
           </a:xfrm>
           <a:prstGeom prst="rect">
@@ -3529,7 +3707,7 @@
         </p:nvSpPr>
         <p:spPr>
           <a:xfrm>
-            <a:off x="6035040" y="2331720"/>
+            <a:off x="6035040" y="1920659"/>
             <a:ext cx="2103120" cy="457200"/>
           </a:xfrm>
           <a:prstGeom prst="rect">
@@ -3565,7 +3743,7 @@
         </p:nvSpPr>
         <p:spPr>
           <a:xfrm>
-            <a:off x="6035040" y="2743200"/>
+            <a:off x="6035040" y="2332139"/>
             <a:ext cx="2103120" cy="320040"/>
           </a:xfrm>
           <a:prstGeom prst="rect">
@@ -3604,7 +3782,7 @@
         </p:nvSpPr>
         <p:spPr>
           <a:xfrm>
-            <a:off x="6035040" y="3063240"/>
+            <a:off x="6035040" y="2652179"/>
             <a:ext cx="2103120" cy="411480"/>
           </a:xfrm>
           <a:prstGeom prst="rect">
@@ -3657,7 +3835,7 @@
         </p:blipFill>
         <p:spPr>
           <a:xfrm>
-            <a:off x="1532890" y="3749040"/>
+            <a:off x="1532890" y="3438647"/>
             <a:ext cx="1231900" cy="1219200"/>
           </a:xfrm>
           <a:prstGeom prst="rect">
@@ -3687,7 +3865,7 @@
         </p:blipFill>
         <p:spPr>
           <a:xfrm>
-            <a:off x="3752850" y="3558540"/>
+            <a:off x="3761239" y="3248147"/>
             <a:ext cx="1638300" cy="1600200"/>
           </a:xfrm>
           <a:prstGeom prst="rect">
@@ -3717,7 +3895,7 @@
         </p:blipFill>
         <p:spPr>
           <a:xfrm>
-            <a:off x="6556844" y="3742690"/>
+            <a:off x="6548455" y="3432297"/>
             <a:ext cx="1231900" cy="1231900"/>
           </a:xfrm>
           <a:prstGeom prst="rect">

</xml_diff>